<commit_message>
docs(slides): adiciona link do repositorio no slide final (PT e EN)
Hyperlink para github.com/IvanYamasaki/trajectory-prediction no slide
de encerramento, no estilo do template (Google Sans, roxo).

Co-Authored-By: Claude Fable 5 <noreply@anthropic.com>
</commit_message>
<xml_diff>
--- a/docs/slides/Seq2Seq Drift - Ivan Yamasaki (EN).pptx
+++ b/docs/slides/Seq2Seq Drift - Ivan Yamasaki (EN).pptx
@@ -13842,6 +13842,42 @@
           </a:p>
         </p:txBody>
       </p:sp>
+      <p:sp>
+        <p:nvSpPr>
+          <p:cNvPr id="395" name="TextBox 394"/>
+          <p:cNvSpPr txBox="1"/>
+          <p:nvPr/>
+        </p:nvSpPr>
+        <p:spPr>
+          <a:xfrm>
+            <a:off x="914400" y="3566160"/>
+            <a:ext cx="7315200" cy="320040"/>
+          </a:xfrm>
+          <a:prstGeom prst="rect">
+            <a:avLst/>
+          </a:prstGeom>
+          <a:noFill/>
+        </p:spPr>
+        <p:txBody>
+          <a:bodyPr wrap="square">
+            <a:spAutoFit/>
+          </a:bodyPr>
+          <a:lstStyle/>
+          <a:p>
+            <a:pPr algn="ctr"/>
+            <a:r>
+              <a:rPr sz="1200" b="0">
+                <a:solidFill>
+                  <a:srgbClr val="8D0DE3"/>
+                </a:solidFill>
+                <a:latin typeface="Google Sans"/>
+                <a:hlinkClick r:id="rId6"/>
+              </a:rPr>
+              <a:t>github.com/IvanYamasaki/trajectory-prediction</a:t>
+            </a:r>
+          </a:p>
+        </p:txBody>
+      </p:sp>
     </p:spTree>
   </p:cSld>
   <p:clrMapOvr>

</xml_diff>